<commit_message>
docs: align audit with clean first-payment flow
</commit_message>
<xml_diff>
--- a/devx-audit/output/xrpl-devx-walkthrough.pptx
+++ b/devx-audit/output/xrpl-devx-walkthrough.pptx
@@ -2,24 +2,24 @@
 <file path=ppt/presentation.xml><?xml version="1.0" encoding="utf-8"?>
 <p:presentation xmlns:p="http://schemas.openxmlformats.org/presentationml/2006/main">
   <p:sldMasterIdLst>
-    <p:sldMasterId xmlns:r="http://schemas.openxmlformats.org/officeDocument/2006/relationships" id="2147483648" r:id="Rb9e186cbea914c75"/>
+    <p:sldMasterId xmlns:r="http://schemas.openxmlformats.org/officeDocument/2006/relationships" id="2147483648" r:id="R41f338263ebe4fc3"/>
   </p:sldMasterIdLst>
   <p:notesMasterIdLst>
-    <p:notesMasterId xmlns:r="http://schemas.openxmlformats.org/officeDocument/2006/relationships" r:id="Rbc0816e0bded4273"/>
+    <p:notesMasterId xmlns:r="http://schemas.openxmlformats.org/officeDocument/2006/relationships" r:id="Ref6bd65bb2dd4e94"/>
   </p:notesMasterIdLst>
   <p:sldIdLst>
-    <p:sldId xmlns:r="http://schemas.openxmlformats.org/officeDocument/2006/relationships" id="256" r:id="Rfe1c5917f03d4c4a"/>
-    <p:sldId xmlns:r="http://schemas.openxmlformats.org/officeDocument/2006/relationships" id="257" r:id="R950cecf26b634ea5"/>
-    <p:sldId xmlns:r="http://schemas.openxmlformats.org/officeDocument/2006/relationships" id="258" r:id="Rcccd954dcad54a6c"/>
-    <p:sldId xmlns:r="http://schemas.openxmlformats.org/officeDocument/2006/relationships" id="259" r:id="R1cda031038884552"/>
-    <p:sldId xmlns:r="http://schemas.openxmlformats.org/officeDocument/2006/relationships" id="260" r:id="Rfd8be5601ddc4f6a"/>
-    <p:sldId xmlns:r="http://schemas.openxmlformats.org/officeDocument/2006/relationships" id="261" r:id="R1a48cf5e0e184010"/>
-    <p:sldId xmlns:r="http://schemas.openxmlformats.org/officeDocument/2006/relationships" id="262" r:id="R70b2f88433e24b2c"/>
-    <p:sldId xmlns:r="http://schemas.openxmlformats.org/officeDocument/2006/relationships" id="263" r:id="R74c603b686cf4861"/>
-    <p:sldId xmlns:r="http://schemas.openxmlformats.org/officeDocument/2006/relationships" id="264" r:id="R4bd5ea4a304444e7"/>
-    <p:sldId xmlns:r="http://schemas.openxmlformats.org/officeDocument/2006/relationships" id="265" r:id="Rd45f2359095242e8"/>
-    <p:sldId xmlns:r="http://schemas.openxmlformats.org/officeDocument/2006/relationships" id="266" r:id="R6ee99485ad8e4e05"/>
-    <p:sldId xmlns:r="http://schemas.openxmlformats.org/officeDocument/2006/relationships" id="267" r:id="R44d87ef00d9b4293"/>
+    <p:sldId xmlns:r="http://schemas.openxmlformats.org/officeDocument/2006/relationships" id="256" r:id="R94bfa6e3d8cb477c"/>
+    <p:sldId xmlns:r="http://schemas.openxmlformats.org/officeDocument/2006/relationships" id="257" r:id="R48d1be83367a4db6"/>
+    <p:sldId xmlns:r="http://schemas.openxmlformats.org/officeDocument/2006/relationships" id="258" r:id="R8046767a040d4e86"/>
+    <p:sldId xmlns:r="http://schemas.openxmlformats.org/officeDocument/2006/relationships" id="259" r:id="Rf329490c45114aab"/>
+    <p:sldId xmlns:r="http://schemas.openxmlformats.org/officeDocument/2006/relationships" id="260" r:id="R0f04d047285a48cd"/>
+    <p:sldId xmlns:r="http://schemas.openxmlformats.org/officeDocument/2006/relationships" id="261" r:id="R47500f43bd814d80"/>
+    <p:sldId xmlns:r="http://schemas.openxmlformats.org/officeDocument/2006/relationships" id="262" r:id="R4c713b769d6f48cb"/>
+    <p:sldId xmlns:r="http://schemas.openxmlformats.org/officeDocument/2006/relationships" id="263" r:id="R4ec9352cbe0841b7"/>
+    <p:sldId xmlns:r="http://schemas.openxmlformats.org/officeDocument/2006/relationships" id="264" r:id="Rfec46f70d2ff4f82"/>
+    <p:sldId xmlns:r="http://schemas.openxmlformats.org/officeDocument/2006/relationships" id="265" r:id="R7e87908a953342b3"/>
+    <p:sldId xmlns:r="http://schemas.openxmlformats.org/officeDocument/2006/relationships" id="266" r:id="R22791e3ff8344588"/>
+    <p:sldId xmlns:r="http://schemas.openxmlformats.org/officeDocument/2006/relationships" id="267" r:id="Rc42d0992cc9a4c4c"/>
   </p:sldIdLst>
   <p:sldSz cx="12192000" cy="6858000"/>
   <p:notesSz cx="6858000" cy="9144000"/>
@@ -973,7 +973,7 @@
           <a:lstStyle xmlns:a="http://schemas.openxmlformats.org/drawingml/2006/main"/>
           <a:p xmlns:a="http://schemas.openxmlformats.org/drawingml/2006/main">
             <a:r>
-              <a:t>The identical draft below uses satisfies Payment. On published5.3.0 it compiles because BaseTransaction extends Record&lt;string,unknown&gt;. The candidate rejects DestinationTagg and suggests DestinationTag. Separate probes verify direct generic request and submission calls, valid inputs, and Omit preserving other required fields. This is not a claim that all invalid transactions can be rejected statically.</a:t>
+              <a:t>The retained published example names Payment with satisfies, but its typo still compiles because BaseTransaction extends Record&lt;string,unknown&gt;. The proposed experience passes the literal directly to submitAndWait. TransactionType drives Payment completions; DestinationTagg is rejected without an extra annotation. Separate probes verify direct generic request and submission calls, valid inputs, and Omit preserving other required fields. This is not a claim that all invalid transactions can be rejected statically.</a:t>
             </a:r>
           </a:p>
           <a:p xmlns:a="http://schemas.openxmlformats.org/drawingml/2006/main">
@@ -1198,7 +1198,7 @@
           <a:lstStyle xmlns:a="http://schemas.openxmlformats.org/drawingml/2006/main"/>
           <a:p xmlns:a="http://schemas.openxmlformats.org/drawingml/2006/main">
             <a:r>
-              <a:t>The prototype validates its promised metadata shape at runtime before presenting a validated parsed response. It does not equate validation with tesSUCCESS. Domain absence checks also remain. Across four paired workflows5 parsed guards,2 ledger-kind comparisons and1 autofill generic disappear. These are source-scaffolding counts, not time-saved or quality-score claims.</a:t>
+              <a:t>The prototype validates its promised metadata shape at runtime before presenting a validated parsed response. It does not equate validation with tesSUCCESS. Domain absence checks also remain. Across four paired workflows5 parsed guards,2 ledger-kind comparisons and1 autofill generic disappear. Getting Started also removes2 satisfies clauses and1 redundant validate call. The main walkthrough now uses the prototype; its5.3.0 comparison is retained separately. Five editor checks and positive/negative real-ledger Getting Started runs pass. These are source-scaffolding counts, not time-saved or quality-score claims.</a:t>
             </a:r>
           </a:p>
           <a:p xmlns:a="http://schemas.openxmlformats.org/drawingml/2006/main">
@@ -1346,7 +1346,7 @@
   </p:cSld>
   <p:clrMap bg1="lt1" tx1="dk1" bg2="lt2" tx2="dk2" accent1="accent1" accent2="accent2" accent3="accent3" accent4="accent4" accent5="accent5" accent6="accent6" hlink="hlink" folHlink="folHlink"/>
   <p:sldLayoutIdLst>
-    <p:sldLayoutId xmlns:r="http://schemas.openxmlformats.org/officeDocument/2006/relationships" id="2147483649" r:id="R86fc59cef4cc4bd9"/>
+    <p:sldLayoutId xmlns:r="http://schemas.openxmlformats.org/officeDocument/2006/relationships" id="2147483649" r:id="R7a017d10b17f4db0"/>
   </p:sldLayoutIdLst>
   <p:txStyles>
     <p:titleStyle>
@@ -1897,7 +1897,7 @@
           <p:cNvPr id="5" name="">
             <a:extLst xmlns:a="http://schemas.openxmlformats.org/drawingml/2006/main">
               <a:ext uri="{FF2B5EF4-FFF2-40B4-BE49-F238E27FC236}">
-                <a16:creationId xmlns:a16="http://schemas.microsoft.com/office/drawing/2014/main" id="{0083F6C9-064E-4AC0-BC22-FD7950EB0E69}"/>
+                <a16:creationId xmlns:a16="http://schemas.microsoft.com/office/drawing/2014/main" id="{1AFB3E0D-0A86-475C-8333-6440C07C64D4}"/>
               </a:ext>
             </a:extLst>
           </p:cNvPr>
@@ -1977,7 +1977,7 @@
           <p:cNvPr id="2" name="">
             <a:extLst xmlns:a="http://schemas.openxmlformats.org/drawingml/2006/main">
               <a:ext uri="{FF2B5EF4-FFF2-40B4-BE49-F238E27FC236}">
-                <a16:creationId xmlns:a16="http://schemas.microsoft.com/office/drawing/2014/main" id="{CA77416B-3E3A-4FC1-99CE-08A0B1325E91}"/>
+                <a16:creationId xmlns:a16="http://schemas.microsoft.com/office/drawing/2014/main" id="{5AD31F58-716D-4E0F-8F53-7244230247DC}"/>
               </a:ext>
             </a:extLst>
           </p:cNvPr>
@@ -2034,7 +2034,7 @@
           <p:cNvPr id="3" name="">
             <a:extLst xmlns:a="http://schemas.openxmlformats.org/drawingml/2006/main">
               <a:ext uri="{FF2B5EF4-FFF2-40B4-BE49-F238E27FC236}">
-                <a16:creationId xmlns:a16="http://schemas.microsoft.com/office/drawing/2014/main" id="{729ED2C2-6CE8-4694-A7FB-88FE7A1C49BF}"/>
+                <a16:creationId xmlns:a16="http://schemas.microsoft.com/office/drawing/2014/main" id="{6FE1112A-2C6A-4D1F-9010-5B6B14C54F3F}"/>
               </a:ext>
             </a:extLst>
           </p:cNvPr>
@@ -2114,7 +2114,7 @@
           <p:cNvPr id="4" name="">
             <a:extLst xmlns:a="http://schemas.openxmlformats.org/drawingml/2006/main">
               <a:ext uri="{FF2B5EF4-FFF2-40B4-BE49-F238E27FC236}">
-                <a16:creationId xmlns:a16="http://schemas.microsoft.com/office/drawing/2014/main" id="{AD7ED854-66F7-4D0A-9500-5B7E16E53A87}"/>
+                <a16:creationId xmlns:a16="http://schemas.microsoft.com/office/drawing/2014/main" id="{0E3506ED-EDBD-4D46-B276-AD8C2DCA8C5F}"/>
               </a:ext>
             </a:extLst>
           </p:cNvPr>
@@ -2192,7 +2192,7 @@
     </p:spTree>
     <p:extLst>
       <p:ext uri="{BB962C8B-B14F-4D97-AF65-F5344CB8AC3E}">
-        <p14:creationId xmlns:p14="http://schemas.microsoft.com/office/powerpoint/2010/main" val="1360643397"/>
+        <p14:creationId xmlns:p14="http://schemas.microsoft.com/office/powerpoint/2010/main" val="342263749"/>
       </p:ext>
     </p:extLst>
   </p:cSld>
@@ -2223,7 +2223,7 @@
           <p:cNvPr id="12" name="">
             <a:extLst xmlns:a="http://schemas.openxmlformats.org/drawingml/2006/main">
               <a:ext uri="{FF2B5EF4-FFF2-40B4-BE49-F238E27FC236}">
-                <a16:creationId xmlns:a16="http://schemas.microsoft.com/office/drawing/2014/main" id="{36D78879-5F73-4866-A610-B547B0341EE7}"/>
+                <a16:creationId xmlns:a16="http://schemas.microsoft.com/office/drawing/2014/main" id="{278A3353-3007-4659-AD62-B12E6B6D3DE6}"/>
               </a:ext>
             </a:extLst>
           </p:cNvPr>
@@ -2280,7 +2280,7 @@
           <p:cNvPr id="2" name="">
             <a:extLst xmlns:a="http://schemas.openxmlformats.org/drawingml/2006/main">
               <a:ext uri="{FF2B5EF4-FFF2-40B4-BE49-F238E27FC236}">
-                <a16:creationId xmlns:a16="http://schemas.microsoft.com/office/drawing/2014/main" id="{EC16CE12-13CF-49C0-AA57-E2A9FEE675C2}"/>
+                <a16:creationId xmlns:a16="http://schemas.microsoft.com/office/drawing/2014/main" id="{93343E67-D064-43FF-AAE9-1C30531107BB}"/>
               </a:ext>
             </a:extLst>
           </p:cNvPr>
@@ -2337,7 +2337,7 @@
           <p:cNvPr id="3" name="">
             <a:extLst xmlns:a="http://schemas.openxmlformats.org/drawingml/2006/main">
               <a:ext uri="{FF2B5EF4-FFF2-40B4-BE49-F238E27FC236}">
-                <a16:creationId xmlns:a16="http://schemas.microsoft.com/office/drawing/2014/main" id="{56D9B3A9-4AC3-49AF-AC7E-BBE5220AF32C}"/>
+                <a16:creationId xmlns:a16="http://schemas.microsoft.com/office/drawing/2014/main" id="{1E9C44BB-44F4-43C6-B542-F5A21F6861F4}"/>
               </a:ext>
             </a:extLst>
           </p:cNvPr>
@@ -2394,7 +2394,7 @@
           <p:cNvPr id="4" name="">
             <a:extLst xmlns:a="http://schemas.openxmlformats.org/drawingml/2006/main">
               <a:ext uri="{FF2B5EF4-FFF2-40B4-BE49-F238E27FC236}">
-                <a16:creationId xmlns:a16="http://schemas.microsoft.com/office/drawing/2014/main" id="{F49DBAAB-5BCE-466D-BCBF-259FC5D03AAA}"/>
+                <a16:creationId xmlns:a16="http://schemas.microsoft.com/office/drawing/2014/main" id="{774CB688-A8F9-4C85-8693-E3B96991118F}"/>
               </a:ext>
             </a:extLst>
           </p:cNvPr>
@@ -2451,7 +2451,7 @@
           <p:cNvPr id="5" name="">
             <a:extLst xmlns:a="http://schemas.openxmlformats.org/drawingml/2006/main">
               <a:ext uri="{FF2B5EF4-FFF2-40B4-BE49-F238E27FC236}">
-                <a16:creationId xmlns:a16="http://schemas.microsoft.com/office/drawing/2014/main" id="{BFED5486-F42D-4753-9745-8A72D4767392}"/>
+                <a16:creationId xmlns:a16="http://schemas.microsoft.com/office/drawing/2014/main" id="{41A00E98-01F8-47D5-825E-B12690A807FE}"/>
               </a:ext>
             </a:extLst>
           </p:cNvPr>
@@ -2508,7 +2508,7 @@
           <p:cNvPr id="6" name="">
             <a:extLst xmlns:a="http://schemas.openxmlformats.org/drawingml/2006/main">
               <a:ext uri="{FF2B5EF4-FFF2-40B4-BE49-F238E27FC236}">
-                <a16:creationId xmlns:a16="http://schemas.microsoft.com/office/drawing/2014/main" id="{8AB7CA77-9160-451D-A324-CFEC1261745E}"/>
+                <a16:creationId xmlns:a16="http://schemas.microsoft.com/office/drawing/2014/main" id="{30D387A9-7BF4-40FE-9636-01862AD6FC81}"/>
               </a:ext>
             </a:extLst>
           </p:cNvPr>
@@ -2565,7 +2565,7 @@
           <p:cNvPr id="7" name="">
             <a:extLst xmlns:a="http://schemas.openxmlformats.org/drawingml/2006/main">
               <a:ext uri="{FF2B5EF4-FFF2-40B4-BE49-F238E27FC236}">
-                <a16:creationId xmlns:a16="http://schemas.microsoft.com/office/drawing/2014/main" id="{8E8FF009-EFC7-4A31-AEA4-8818BF0A0F25}"/>
+                <a16:creationId xmlns:a16="http://schemas.microsoft.com/office/drawing/2014/main" id="{46F5F9D2-79A9-4ECA-9D21-3986D78267C5}"/>
               </a:ext>
             </a:extLst>
           </p:cNvPr>
@@ -2622,7 +2622,7 @@
           <p:cNvPr id="8" name="">
             <a:extLst xmlns:a="http://schemas.openxmlformats.org/drawingml/2006/main">
               <a:ext uri="{FF2B5EF4-FFF2-40B4-BE49-F238E27FC236}">
-                <a16:creationId xmlns:a16="http://schemas.microsoft.com/office/drawing/2014/main" id="{21B13FA9-BC4E-4357-A68E-5D0EFC1027CF}"/>
+                <a16:creationId xmlns:a16="http://schemas.microsoft.com/office/drawing/2014/main" id="{127EE18A-2BE5-4B47-ADB4-70601CC67188}"/>
               </a:ext>
             </a:extLst>
           </p:cNvPr>
@@ -2679,7 +2679,7 @@
           <p:cNvPr id="9" name="">
             <a:extLst xmlns:a="http://schemas.openxmlformats.org/drawingml/2006/main">
               <a:ext uri="{FF2B5EF4-FFF2-40B4-BE49-F238E27FC236}">
-                <a16:creationId xmlns:a16="http://schemas.microsoft.com/office/drawing/2014/main" id="{D6059348-2B67-4552-92A1-6FC234E4EB37}"/>
+                <a16:creationId xmlns:a16="http://schemas.microsoft.com/office/drawing/2014/main" id="{B850CD7A-F56A-4988-A9A9-F40C35FE8057}"/>
               </a:ext>
             </a:extLst>
           </p:cNvPr>
@@ -2736,7 +2736,7 @@
           <p:cNvPr id="10" name="">
             <a:extLst xmlns:a="http://schemas.openxmlformats.org/drawingml/2006/main">
               <a:ext uri="{FF2B5EF4-FFF2-40B4-BE49-F238E27FC236}">
-                <a16:creationId xmlns:a16="http://schemas.microsoft.com/office/drawing/2014/main" id="{6A1BD701-14CF-4A5B-9A84-738C5EB944C6}"/>
+                <a16:creationId xmlns:a16="http://schemas.microsoft.com/office/drawing/2014/main" id="{9506D55F-5D2D-45FC-9648-E4AAE0D84384}"/>
               </a:ext>
             </a:extLst>
           </p:cNvPr>
@@ -2793,7 +2793,7 @@
           <p:cNvPr id="11" name="">
             <a:extLst xmlns:a="http://schemas.openxmlformats.org/drawingml/2006/main">
               <a:ext uri="{FF2B5EF4-FFF2-40B4-BE49-F238E27FC236}">
-                <a16:creationId xmlns:a16="http://schemas.microsoft.com/office/drawing/2014/main" id="{D0448F4E-2581-446F-AB92-E08C1B53E9BF}"/>
+                <a16:creationId xmlns:a16="http://schemas.microsoft.com/office/drawing/2014/main" id="{FD44704D-5413-4017-AFDF-BB6CFFEB7A7E}"/>
               </a:ext>
             </a:extLst>
           </p:cNvPr>
@@ -2848,7 +2848,7 @@
     </p:spTree>
     <p:extLst>
       <p:ext uri="{BB962C8B-B14F-4D97-AF65-F5344CB8AC3E}">
-        <p14:creationId xmlns:p14="http://schemas.microsoft.com/office/powerpoint/2010/main" val="1552719397"/>
+        <p14:creationId xmlns:p14="http://schemas.microsoft.com/office/powerpoint/2010/main" val="1913727199"/>
       </p:ext>
     </p:extLst>
   </p:cSld>
@@ -2879,7 +2879,7 @@
           <p:cNvPr id="11" name="">
             <a:extLst xmlns:a="http://schemas.openxmlformats.org/drawingml/2006/main">
               <a:ext uri="{FF2B5EF4-FFF2-40B4-BE49-F238E27FC236}">
-                <a16:creationId xmlns:a16="http://schemas.microsoft.com/office/drawing/2014/main" id="{EE311292-90B9-448A-822E-9D498FD8DBDC}"/>
+                <a16:creationId xmlns:a16="http://schemas.microsoft.com/office/drawing/2014/main" id="{E58852E3-FC2D-4ED7-AE53-AA70647E3FE3}"/>
               </a:ext>
             </a:extLst>
           </p:cNvPr>
@@ -2936,7 +2936,7 @@
           <p:cNvPr id="2" name="">
             <a:extLst xmlns:a="http://schemas.openxmlformats.org/drawingml/2006/main">
               <a:ext uri="{FF2B5EF4-FFF2-40B4-BE49-F238E27FC236}">
-                <a16:creationId xmlns:a16="http://schemas.microsoft.com/office/drawing/2014/main" id="{3FD85FA0-5A06-4197-8B90-46022FF4C3A0}"/>
+                <a16:creationId xmlns:a16="http://schemas.microsoft.com/office/drawing/2014/main" id="{6D73994C-55DC-43B5-9F66-811F05EB7661}"/>
               </a:ext>
             </a:extLst>
           </p:cNvPr>
@@ -2993,7 +2993,7 @@
           <p:cNvPr id="3" name="">
             <a:extLst xmlns:a="http://schemas.openxmlformats.org/drawingml/2006/main">
               <a:ext uri="{FF2B5EF4-FFF2-40B4-BE49-F238E27FC236}">
-                <a16:creationId xmlns:a16="http://schemas.microsoft.com/office/drawing/2014/main" id="{14ADAC8A-3481-4B03-93CD-C8F054DD7E7E}"/>
+                <a16:creationId xmlns:a16="http://schemas.microsoft.com/office/drawing/2014/main" id="{41ADF466-3375-4257-B7E8-0963D5F850D8}"/>
               </a:ext>
             </a:extLst>
           </p:cNvPr>
@@ -3050,7 +3050,7 @@
           <p:cNvPr id="4" name="">
             <a:extLst xmlns:a="http://schemas.openxmlformats.org/drawingml/2006/main">
               <a:ext uri="{FF2B5EF4-FFF2-40B4-BE49-F238E27FC236}">
-                <a16:creationId xmlns:a16="http://schemas.microsoft.com/office/drawing/2014/main" id="{0344AAE0-4029-41E3-AA91-E072F89DB0EC}"/>
+                <a16:creationId xmlns:a16="http://schemas.microsoft.com/office/drawing/2014/main" id="{666582C4-98F0-47B8-B64B-79D31B785B2F}"/>
               </a:ext>
             </a:extLst>
           </p:cNvPr>
@@ -3107,7 +3107,7 @@
           <p:cNvPr id="5" name="">
             <a:extLst xmlns:a="http://schemas.openxmlformats.org/drawingml/2006/main">
               <a:ext uri="{FF2B5EF4-FFF2-40B4-BE49-F238E27FC236}">
-                <a16:creationId xmlns:a16="http://schemas.microsoft.com/office/drawing/2014/main" id="{E37FB388-DF7B-4CFC-99E6-501CDB2F9C7D}"/>
+                <a16:creationId xmlns:a16="http://schemas.microsoft.com/office/drawing/2014/main" id="{06F07AA9-AA9D-4409-8077-B980FE60C1E7}"/>
               </a:ext>
             </a:extLst>
           </p:cNvPr>
@@ -3164,7 +3164,7 @@
           <p:cNvPr id="6" name="">
             <a:extLst xmlns:a="http://schemas.openxmlformats.org/drawingml/2006/main">
               <a:ext uri="{FF2B5EF4-FFF2-40B4-BE49-F238E27FC236}">
-                <a16:creationId xmlns:a16="http://schemas.microsoft.com/office/drawing/2014/main" id="{24E9C66E-9C36-4A16-B03E-0EB7F1605B7B}"/>
+                <a16:creationId xmlns:a16="http://schemas.microsoft.com/office/drawing/2014/main" id="{01FE8BCA-F2CC-4A9F-8485-B37E7DE16853}"/>
               </a:ext>
             </a:extLst>
           </p:cNvPr>
@@ -3221,7 +3221,7 @@
           <p:cNvPr id="7" name="">
             <a:extLst xmlns:a="http://schemas.openxmlformats.org/drawingml/2006/main">
               <a:ext uri="{FF2B5EF4-FFF2-40B4-BE49-F238E27FC236}">
-                <a16:creationId xmlns:a16="http://schemas.microsoft.com/office/drawing/2014/main" id="{5D5935C5-8CBC-45E8-A6ED-53977146F813}"/>
+                <a16:creationId xmlns:a16="http://schemas.microsoft.com/office/drawing/2014/main" id="{32CE7D57-1E5E-42F3-A482-2D1D2F1B5EE1}"/>
               </a:ext>
             </a:extLst>
           </p:cNvPr>
@@ -3278,7 +3278,7 @@
           <p:cNvPr id="8" name="">
             <a:extLst xmlns:a="http://schemas.openxmlformats.org/drawingml/2006/main">
               <a:ext uri="{FF2B5EF4-FFF2-40B4-BE49-F238E27FC236}">
-                <a16:creationId xmlns:a16="http://schemas.microsoft.com/office/drawing/2014/main" id="{D8D70723-E528-45C7-9579-F863285DD739}"/>
+                <a16:creationId xmlns:a16="http://schemas.microsoft.com/office/drawing/2014/main" id="{22C97FC2-583C-4586-A7A8-EC0F16402513}"/>
               </a:ext>
             </a:extLst>
           </p:cNvPr>
@@ -3335,7 +3335,7 @@
           <p:cNvPr id="9" name="">
             <a:extLst xmlns:a="http://schemas.openxmlformats.org/drawingml/2006/main">
               <a:ext uri="{FF2B5EF4-FFF2-40B4-BE49-F238E27FC236}">
-                <a16:creationId xmlns:a16="http://schemas.microsoft.com/office/drawing/2014/main" id="{AD2C44D3-781D-4AFA-A07F-EF532CEDF16D}"/>
+                <a16:creationId xmlns:a16="http://schemas.microsoft.com/office/drawing/2014/main" id="{36C1B411-DA4F-44CA-9B90-6BD1436D4969}"/>
               </a:ext>
             </a:extLst>
           </p:cNvPr>
@@ -3392,7 +3392,7 @@
           <p:cNvPr id="10" name="">
             <a:extLst xmlns:a="http://schemas.openxmlformats.org/drawingml/2006/main">
               <a:ext uri="{FF2B5EF4-FFF2-40B4-BE49-F238E27FC236}">
-                <a16:creationId xmlns:a16="http://schemas.microsoft.com/office/drawing/2014/main" id="{9B000D1A-41D3-438F-8135-07B8DCDBCC73}"/>
+                <a16:creationId xmlns:a16="http://schemas.microsoft.com/office/drawing/2014/main" id="{AA723140-7B4B-49DB-9E01-B86F4B9FFCE8}"/>
               </a:ext>
             </a:extLst>
           </p:cNvPr>
@@ -3447,7 +3447,7 @@
     </p:spTree>
     <p:extLst>
       <p:ext uri="{BB962C8B-B14F-4D97-AF65-F5344CB8AC3E}">
-        <p14:creationId xmlns:p14="http://schemas.microsoft.com/office/powerpoint/2010/main" val="1625911739"/>
+        <p14:creationId xmlns:p14="http://schemas.microsoft.com/office/powerpoint/2010/main" val="2120012563"/>
       </p:ext>
     </p:extLst>
   </p:cSld>
@@ -3478,7 +3478,7 @@
           <p:cNvPr id="6" name="">
             <a:extLst xmlns:a="http://schemas.openxmlformats.org/drawingml/2006/main">
               <a:ext uri="{FF2B5EF4-FFF2-40B4-BE49-F238E27FC236}">
-                <a16:creationId xmlns:a16="http://schemas.microsoft.com/office/drawing/2014/main" id="{9285CC9F-73FE-44B4-A9BB-0EEFFC5D6A61}"/>
+                <a16:creationId xmlns:a16="http://schemas.microsoft.com/office/drawing/2014/main" id="{A31D84BE-8BCD-42C0-8882-7E6C89CB5AD3}"/>
               </a:ext>
             </a:extLst>
           </p:cNvPr>
@@ -3535,7 +3535,7 @@
           <p:cNvPr id="2" name="">
             <a:extLst xmlns:a="http://schemas.openxmlformats.org/drawingml/2006/main">
               <a:ext uri="{FF2B5EF4-FFF2-40B4-BE49-F238E27FC236}">
-                <a16:creationId xmlns:a16="http://schemas.microsoft.com/office/drawing/2014/main" id="{434F81D9-B9D1-48B1-8C1B-E317518038E5}"/>
+                <a16:creationId xmlns:a16="http://schemas.microsoft.com/office/drawing/2014/main" id="{3530068A-D368-4750-9EE6-C27215FE8BE8}"/>
               </a:ext>
             </a:extLst>
           </p:cNvPr>
@@ -3592,7 +3592,7 @@
           <p:cNvPr id="3" name="">
             <a:extLst xmlns:a="http://schemas.openxmlformats.org/drawingml/2006/main">
               <a:ext uri="{FF2B5EF4-FFF2-40B4-BE49-F238E27FC236}">
-                <a16:creationId xmlns:a16="http://schemas.microsoft.com/office/drawing/2014/main" id="{5C40AC95-27DB-47C7-BB10-C0C64DB940FB}"/>
+                <a16:creationId xmlns:a16="http://schemas.microsoft.com/office/drawing/2014/main" id="{C124748E-8E90-46F4-A977-A930310E6536}"/>
               </a:ext>
             </a:extLst>
           </p:cNvPr>
@@ -3672,7 +3672,7 @@
           <p:cNvPr id="4" name="">
             <a:extLst xmlns:a="http://schemas.openxmlformats.org/drawingml/2006/main">
               <a:ext uri="{FF2B5EF4-FFF2-40B4-BE49-F238E27FC236}">
-                <a16:creationId xmlns:a16="http://schemas.microsoft.com/office/drawing/2014/main" id="{1C5ACAFE-11FC-4D98-9EA9-6CCA6B31FED3}"/>
+                <a16:creationId xmlns:a16="http://schemas.microsoft.com/office/drawing/2014/main" id="{95ACB529-0B7D-4F50-96F3-E0D0B82C7EEA}"/>
               </a:ext>
             </a:extLst>
           </p:cNvPr>
@@ -3752,7 +3752,7 @@
           <p:cNvPr id="5" name="">
             <a:extLst xmlns:a="http://schemas.openxmlformats.org/drawingml/2006/main">
               <a:ext uri="{FF2B5EF4-FFF2-40B4-BE49-F238E27FC236}">
-                <a16:creationId xmlns:a16="http://schemas.microsoft.com/office/drawing/2014/main" id="{B928963D-9603-4A99-936E-78C82DC5B240}"/>
+                <a16:creationId xmlns:a16="http://schemas.microsoft.com/office/drawing/2014/main" id="{449D94FE-7AC4-43F8-B8B0-90B3E5865D36}"/>
               </a:ext>
             </a:extLst>
           </p:cNvPr>
@@ -3830,7 +3830,7 @@
     </p:spTree>
     <p:extLst>
       <p:ext uri="{BB962C8B-B14F-4D97-AF65-F5344CB8AC3E}">
-        <p14:creationId xmlns:p14="http://schemas.microsoft.com/office/powerpoint/2010/main" val="217330017"/>
+        <p14:creationId xmlns:p14="http://schemas.microsoft.com/office/powerpoint/2010/main" val="292383290"/>
       </p:ext>
     </p:extLst>
   </p:cSld>
@@ -3861,7 +3861,7 @@
           <p:cNvPr id="11" name="">
             <a:extLst xmlns:a="http://schemas.openxmlformats.org/drawingml/2006/main">
               <a:ext uri="{FF2B5EF4-FFF2-40B4-BE49-F238E27FC236}">
-                <a16:creationId xmlns:a16="http://schemas.microsoft.com/office/drawing/2014/main" id="{F062B7A1-8180-431A-A2B5-CAA20AB5E46A}"/>
+                <a16:creationId xmlns:a16="http://schemas.microsoft.com/office/drawing/2014/main" id="{7FE74C74-BBA8-43C1-A4E4-08FBBCE20A7E}"/>
               </a:ext>
             </a:extLst>
           </p:cNvPr>
@@ -3918,7 +3918,7 @@
           <p:cNvPr id="2" name="">
             <a:extLst xmlns:a="http://schemas.openxmlformats.org/drawingml/2006/main">
               <a:ext uri="{FF2B5EF4-FFF2-40B4-BE49-F238E27FC236}">
-                <a16:creationId xmlns:a16="http://schemas.microsoft.com/office/drawing/2014/main" id="{3B4A5A89-65D8-4874-AAC8-7361F0616646}"/>
+                <a16:creationId xmlns:a16="http://schemas.microsoft.com/office/drawing/2014/main" id="{E1B71178-BF23-487D-BB8F-C81273CC5D75}"/>
               </a:ext>
             </a:extLst>
           </p:cNvPr>
@@ -3975,7 +3975,7 @@
           <p:cNvPr id="3" name="">
             <a:extLst xmlns:a="http://schemas.openxmlformats.org/drawingml/2006/main">
               <a:ext uri="{FF2B5EF4-FFF2-40B4-BE49-F238E27FC236}">
-                <a16:creationId xmlns:a16="http://schemas.microsoft.com/office/drawing/2014/main" id="{78CB4F18-E811-478F-96CB-BC998AB88DDD}"/>
+                <a16:creationId xmlns:a16="http://schemas.microsoft.com/office/drawing/2014/main" id="{44860BDA-259C-4EB9-911D-CC455EC3FB99}"/>
               </a:ext>
             </a:extLst>
           </p:cNvPr>
@@ -4032,7 +4032,7 @@
           <p:cNvPr id="4" name="">
             <a:extLst xmlns:a="http://schemas.openxmlformats.org/drawingml/2006/main">
               <a:ext uri="{FF2B5EF4-FFF2-40B4-BE49-F238E27FC236}">
-                <a16:creationId xmlns:a16="http://schemas.microsoft.com/office/drawing/2014/main" id="{1CE869EB-0585-4C61-BF27-D01231B1FE99}"/>
+                <a16:creationId xmlns:a16="http://schemas.microsoft.com/office/drawing/2014/main" id="{38A27848-EA0B-4F9B-9E1B-3295BA50F872}"/>
               </a:ext>
             </a:extLst>
           </p:cNvPr>
@@ -4089,7 +4089,7 @@
           <p:cNvPr id="5" name="">
             <a:extLst xmlns:a="http://schemas.openxmlformats.org/drawingml/2006/main">
               <a:ext uri="{FF2B5EF4-FFF2-40B4-BE49-F238E27FC236}">
-                <a16:creationId xmlns:a16="http://schemas.microsoft.com/office/drawing/2014/main" id="{CAB0E76D-C14F-4855-9BE1-FDEB239B603C}"/>
+                <a16:creationId xmlns:a16="http://schemas.microsoft.com/office/drawing/2014/main" id="{94CA72B3-6D1D-4940-93B2-7D8AE242FBAF}"/>
               </a:ext>
             </a:extLst>
           </p:cNvPr>
@@ -4169,7 +4169,7 @@
           <p:cNvPr id="6" name="">
             <a:extLst xmlns:a="http://schemas.openxmlformats.org/drawingml/2006/main">
               <a:ext uri="{FF2B5EF4-FFF2-40B4-BE49-F238E27FC236}">
-                <a16:creationId xmlns:a16="http://schemas.microsoft.com/office/drawing/2014/main" id="{37B82FF7-BFDB-4D7A-9496-39F3EF82AF22}"/>
+                <a16:creationId xmlns:a16="http://schemas.microsoft.com/office/drawing/2014/main" id="{1C74511A-5165-4B0B-99D4-32E12B90B91A}"/>
               </a:ext>
             </a:extLst>
           </p:cNvPr>
@@ -4226,7 +4226,7 @@
           <p:cNvPr id="7" name="">
             <a:extLst xmlns:a="http://schemas.openxmlformats.org/drawingml/2006/main">
               <a:ext uri="{FF2B5EF4-FFF2-40B4-BE49-F238E27FC236}">
-                <a16:creationId xmlns:a16="http://schemas.microsoft.com/office/drawing/2014/main" id="{B0AC9EC7-83DB-4A79-AC72-653E9F689F96}"/>
+                <a16:creationId xmlns:a16="http://schemas.microsoft.com/office/drawing/2014/main" id="{54316E95-5A13-4531-B292-FEAC4A2CFF2F}"/>
               </a:ext>
             </a:extLst>
           </p:cNvPr>
@@ -4306,7 +4306,7 @@
           <p:cNvPr id="8" name="">
             <a:extLst xmlns:a="http://schemas.openxmlformats.org/drawingml/2006/main">
               <a:ext uri="{FF2B5EF4-FFF2-40B4-BE49-F238E27FC236}">
-                <a16:creationId xmlns:a16="http://schemas.microsoft.com/office/drawing/2014/main" id="{EBA12308-ED6D-411F-9EEF-5B65A1CC13A8}"/>
+                <a16:creationId xmlns:a16="http://schemas.microsoft.com/office/drawing/2014/main" id="{01899AA3-A5A3-4C35-8EE4-47DE00C0EDA1}"/>
               </a:ext>
             </a:extLst>
           </p:cNvPr>
@@ -4363,7 +4363,7 @@
           <p:cNvPr id="9" name="">
             <a:extLst xmlns:a="http://schemas.openxmlformats.org/drawingml/2006/main">
               <a:ext uri="{FF2B5EF4-FFF2-40B4-BE49-F238E27FC236}">
-                <a16:creationId xmlns:a16="http://schemas.microsoft.com/office/drawing/2014/main" id="{90A4C5D2-BF19-4377-960A-444795B60A7A}"/>
+                <a16:creationId xmlns:a16="http://schemas.microsoft.com/office/drawing/2014/main" id="{19208BFF-572C-49B3-89A9-112C43B77E7A}"/>
               </a:ext>
             </a:extLst>
           </p:cNvPr>
@@ -4443,7 +4443,7 @@
           <p:cNvPr id="10" name="">
             <a:extLst xmlns:a="http://schemas.openxmlformats.org/drawingml/2006/main">
               <a:ext uri="{FF2B5EF4-FFF2-40B4-BE49-F238E27FC236}">
-                <a16:creationId xmlns:a16="http://schemas.microsoft.com/office/drawing/2014/main" id="{8708BE72-D542-437D-BC5C-913A83207110}"/>
+                <a16:creationId xmlns:a16="http://schemas.microsoft.com/office/drawing/2014/main" id="{1DE9DCCD-33D4-4B52-BD2A-7E9F4ABD8207}"/>
               </a:ext>
             </a:extLst>
           </p:cNvPr>
@@ -4498,7 +4498,7 @@
     </p:spTree>
     <p:extLst>
       <p:ext uri="{BB962C8B-B14F-4D97-AF65-F5344CB8AC3E}">
-        <p14:creationId xmlns:p14="http://schemas.microsoft.com/office/powerpoint/2010/main" val="1894995903"/>
+        <p14:creationId xmlns:p14="http://schemas.microsoft.com/office/powerpoint/2010/main" val="1183561894"/>
       </p:ext>
     </p:extLst>
   </p:cSld>
@@ -4529,7 +4529,7 @@
           <p:cNvPr id="11" name="">
             <a:extLst xmlns:a="http://schemas.openxmlformats.org/drawingml/2006/main">
               <a:ext uri="{FF2B5EF4-FFF2-40B4-BE49-F238E27FC236}">
-                <a16:creationId xmlns:a16="http://schemas.microsoft.com/office/drawing/2014/main" id="{F9D3F223-0823-4D5E-945C-5E788D2D5162}"/>
+                <a16:creationId xmlns:a16="http://schemas.microsoft.com/office/drawing/2014/main" id="{DE4CA4CE-FF9C-42A5-92A2-9DBCC50D4633}"/>
               </a:ext>
             </a:extLst>
           </p:cNvPr>
@@ -4586,7 +4586,7 @@
           <p:cNvPr id="2" name="">
             <a:extLst xmlns:a="http://schemas.openxmlformats.org/drawingml/2006/main">
               <a:ext uri="{FF2B5EF4-FFF2-40B4-BE49-F238E27FC236}">
-                <a16:creationId xmlns:a16="http://schemas.microsoft.com/office/drawing/2014/main" id="{813C9807-0219-434D-A1DE-163FD0042BCE}"/>
+                <a16:creationId xmlns:a16="http://schemas.microsoft.com/office/drawing/2014/main" id="{95F191A0-5301-4B9E-966A-EB9E55317B8B}"/>
               </a:ext>
             </a:extLst>
           </p:cNvPr>
@@ -4643,7 +4643,7 @@
           <p:cNvPr id="3" name="">
             <a:extLst xmlns:a="http://schemas.openxmlformats.org/drawingml/2006/main">
               <a:ext uri="{FF2B5EF4-FFF2-40B4-BE49-F238E27FC236}">
-                <a16:creationId xmlns:a16="http://schemas.microsoft.com/office/drawing/2014/main" id="{459E4880-E769-4936-A02B-DAEDDAE94668}"/>
+                <a16:creationId xmlns:a16="http://schemas.microsoft.com/office/drawing/2014/main" id="{628AF501-7F17-4B5D-8FCE-3012B7E058C3}"/>
               </a:ext>
             </a:extLst>
           </p:cNvPr>
@@ -4700,7 +4700,7 @@
           <p:cNvPr id="4" name="">
             <a:extLst xmlns:a="http://schemas.openxmlformats.org/drawingml/2006/main">
               <a:ext uri="{FF2B5EF4-FFF2-40B4-BE49-F238E27FC236}">
-                <a16:creationId xmlns:a16="http://schemas.microsoft.com/office/drawing/2014/main" id="{885DBFED-30B2-4E9F-8330-B44B5B4476A8}"/>
+                <a16:creationId xmlns:a16="http://schemas.microsoft.com/office/drawing/2014/main" id="{B1643E5C-2626-4E6E-963F-D6BE25D36969}"/>
               </a:ext>
             </a:extLst>
           </p:cNvPr>
@@ -4757,7 +4757,7 @@
           <p:cNvPr id="5" name="">
             <a:extLst xmlns:a="http://schemas.openxmlformats.org/drawingml/2006/main">
               <a:ext uri="{FF2B5EF4-FFF2-40B4-BE49-F238E27FC236}">
-                <a16:creationId xmlns:a16="http://schemas.microsoft.com/office/drawing/2014/main" id="{3202D581-EC27-4C05-BF52-9964F1588022}"/>
+                <a16:creationId xmlns:a16="http://schemas.microsoft.com/office/drawing/2014/main" id="{2217D622-4565-41E1-92E1-6BA09BC2A881}"/>
               </a:ext>
             </a:extLst>
           </p:cNvPr>
@@ -4814,7 +4814,7 @@
           <p:cNvPr id="6" name="">
             <a:extLst xmlns:a="http://schemas.openxmlformats.org/drawingml/2006/main">
               <a:ext uri="{FF2B5EF4-FFF2-40B4-BE49-F238E27FC236}">
-                <a16:creationId xmlns:a16="http://schemas.microsoft.com/office/drawing/2014/main" id="{01942CE3-B21E-4D14-97D3-4679B51FD6BB}"/>
+                <a16:creationId xmlns:a16="http://schemas.microsoft.com/office/drawing/2014/main" id="{D18483C9-28CF-4428-BCC1-E63E89035FE7}"/>
               </a:ext>
             </a:extLst>
           </p:cNvPr>
@@ -4871,7 +4871,7 @@
           <p:cNvPr id="7" name="">
             <a:extLst xmlns:a="http://schemas.openxmlformats.org/drawingml/2006/main">
               <a:ext uri="{FF2B5EF4-FFF2-40B4-BE49-F238E27FC236}">
-                <a16:creationId xmlns:a16="http://schemas.microsoft.com/office/drawing/2014/main" id="{6E3D247E-EBD5-4473-86C3-B03AFF5B554E}"/>
+                <a16:creationId xmlns:a16="http://schemas.microsoft.com/office/drawing/2014/main" id="{1270A4FD-5B99-4A8F-9F40-F8BCD0528A75}"/>
               </a:ext>
             </a:extLst>
           </p:cNvPr>
@@ -4928,7 +4928,7 @@
           <p:cNvPr id="8" name="">
             <a:extLst xmlns:a="http://schemas.openxmlformats.org/drawingml/2006/main">
               <a:ext uri="{FF2B5EF4-FFF2-40B4-BE49-F238E27FC236}">
-                <a16:creationId xmlns:a16="http://schemas.microsoft.com/office/drawing/2014/main" id="{F50C3AB3-56C5-44B5-961C-E5DC3EE995DE}"/>
+                <a16:creationId xmlns:a16="http://schemas.microsoft.com/office/drawing/2014/main" id="{8E55A1CE-AA8C-434F-9969-3D646047950A}"/>
               </a:ext>
             </a:extLst>
           </p:cNvPr>
@@ -4985,7 +4985,7 @@
           <p:cNvPr id="9" name="">
             <a:extLst xmlns:a="http://schemas.openxmlformats.org/drawingml/2006/main">
               <a:ext uri="{FF2B5EF4-FFF2-40B4-BE49-F238E27FC236}">
-                <a16:creationId xmlns:a16="http://schemas.microsoft.com/office/drawing/2014/main" id="{0A75B68E-5901-4F73-BD62-80C81E8D5C8B}"/>
+                <a16:creationId xmlns:a16="http://schemas.microsoft.com/office/drawing/2014/main" id="{2B82C485-DBD7-4AFE-BEEA-B9E476464422}"/>
               </a:ext>
             </a:extLst>
           </p:cNvPr>
@@ -5042,7 +5042,7 @@
           <p:cNvPr id="10" name="">
             <a:extLst xmlns:a="http://schemas.openxmlformats.org/drawingml/2006/main">
               <a:ext uri="{FF2B5EF4-FFF2-40B4-BE49-F238E27FC236}">
-                <a16:creationId xmlns:a16="http://schemas.microsoft.com/office/drawing/2014/main" id="{680499D0-6ED0-4326-AB55-A16FD8C091B1}"/>
+                <a16:creationId xmlns:a16="http://schemas.microsoft.com/office/drawing/2014/main" id="{109FD16D-6310-47DA-8D75-5E788B8BF2EE}"/>
               </a:ext>
             </a:extLst>
           </p:cNvPr>
@@ -5097,7 +5097,7 @@
     </p:spTree>
     <p:extLst>
       <p:ext uri="{BB962C8B-B14F-4D97-AF65-F5344CB8AC3E}">
-        <p14:creationId xmlns:p14="http://schemas.microsoft.com/office/powerpoint/2010/main" val="1188562381"/>
+        <p14:creationId xmlns:p14="http://schemas.microsoft.com/office/powerpoint/2010/main" val="770352893"/>
       </p:ext>
     </p:extLst>
   </p:cSld>
@@ -5128,7 +5128,7 @@
           <p:cNvPr id="11" name="">
             <a:extLst xmlns:a="http://schemas.openxmlformats.org/drawingml/2006/main">
               <a:ext uri="{FF2B5EF4-FFF2-40B4-BE49-F238E27FC236}">
-                <a16:creationId xmlns:a16="http://schemas.microsoft.com/office/drawing/2014/main" id="{AF02A8D5-03A2-4A38-9368-AE2F5E5438C2}"/>
+                <a16:creationId xmlns:a16="http://schemas.microsoft.com/office/drawing/2014/main" id="{89C2A355-E9C9-4515-9AC2-86A9006E66B0}"/>
               </a:ext>
             </a:extLst>
           </p:cNvPr>
@@ -5185,7 +5185,7 @@
           <p:cNvPr id="2" name="">
             <a:extLst xmlns:a="http://schemas.openxmlformats.org/drawingml/2006/main">
               <a:ext uri="{FF2B5EF4-FFF2-40B4-BE49-F238E27FC236}">
-                <a16:creationId xmlns:a16="http://schemas.microsoft.com/office/drawing/2014/main" id="{59BDCC6A-C2BF-4518-9873-FD24F555DF95}"/>
+                <a16:creationId xmlns:a16="http://schemas.microsoft.com/office/drawing/2014/main" id="{DADEDC3D-E548-4226-858F-7E49B0EE96B3}"/>
               </a:ext>
             </a:extLst>
           </p:cNvPr>
@@ -5242,7 +5242,7 @@
           <p:cNvPr id="3" name="">
             <a:extLst xmlns:a="http://schemas.openxmlformats.org/drawingml/2006/main">
               <a:ext uri="{FF2B5EF4-FFF2-40B4-BE49-F238E27FC236}">
-                <a16:creationId xmlns:a16="http://schemas.microsoft.com/office/drawing/2014/main" id="{7BA88012-487B-411B-BD67-A051A9A58B9C}"/>
+                <a16:creationId xmlns:a16="http://schemas.microsoft.com/office/drawing/2014/main" id="{43FB1909-6087-431E-879F-50F136215AF6}"/>
               </a:ext>
             </a:extLst>
           </p:cNvPr>
@@ -5299,7 +5299,7 @@
           <p:cNvPr id="4" name="">
             <a:extLst xmlns:a="http://schemas.openxmlformats.org/drawingml/2006/main">
               <a:ext uri="{FF2B5EF4-FFF2-40B4-BE49-F238E27FC236}">
-                <a16:creationId xmlns:a16="http://schemas.microsoft.com/office/drawing/2014/main" id="{6E29F4AC-5006-452A-BE29-4320689CD864}"/>
+                <a16:creationId xmlns:a16="http://schemas.microsoft.com/office/drawing/2014/main" id="{356C24F0-60CB-418D-BE0E-DCCC93F9DB19}"/>
               </a:ext>
             </a:extLst>
           </p:cNvPr>
@@ -5356,7 +5356,7 @@
           <p:cNvPr id="5" name="">
             <a:extLst xmlns:a="http://schemas.openxmlformats.org/drawingml/2006/main">
               <a:ext uri="{FF2B5EF4-FFF2-40B4-BE49-F238E27FC236}">
-                <a16:creationId xmlns:a16="http://schemas.microsoft.com/office/drawing/2014/main" id="{7756D588-FCF4-4F0D-95BC-FBFAEAE325ED}"/>
+                <a16:creationId xmlns:a16="http://schemas.microsoft.com/office/drawing/2014/main" id="{82D8E55C-1C1F-45DA-9978-993DA829AECE}"/>
               </a:ext>
             </a:extLst>
           </p:cNvPr>
@@ -5413,7 +5413,7 @@
           <p:cNvPr id="6" name="">
             <a:extLst xmlns:a="http://schemas.openxmlformats.org/drawingml/2006/main">
               <a:ext uri="{FF2B5EF4-FFF2-40B4-BE49-F238E27FC236}">
-                <a16:creationId xmlns:a16="http://schemas.microsoft.com/office/drawing/2014/main" id="{0D6092E1-E017-4704-8F71-28904F3D9471}"/>
+                <a16:creationId xmlns:a16="http://schemas.microsoft.com/office/drawing/2014/main" id="{F7EDDDF7-430B-4EE8-9D30-8138C67370DF}"/>
               </a:ext>
             </a:extLst>
           </p:cNvPr>
@@ -5493,7 +5493,7 @@
           <p:cNvPr id="7" name="">
             <a:extLst xmlns:a="http://schemas.openxmlformats.org/drawingml/2006/main">
               <a:ext uri="{FF2B5EF4-FFF2-40B4-BE49-F238E27FC236}">
-                <a16:creationId xmlns:a16="http://schemas.microsoft.com/office/drawing/2014/main" id="{546638FE-6D17-4E3C-9A09-C7D02E69A9FD}"/>
+                <a16:creationId xmlns:a16="http://schemas.microsoft.com/office/drawing/2014/main" id="{92CCE43D-0CA8-48A0-AA8C-3C97FE271B7F}"/>
               </a:ext>
             </a:extLst>
           </p:cNvPr>
@@ -5550,7 +5550,7 @@
           <p:cNvPr id="8" name="">
             <a:extLst xmlns:a="http://schemas.openxmlformats.org/drawingml/2006/main">
               <a:ext uri="{FF2B5EF4-FFF2-40B4-BE49-F238E27FC236}">
-                <a16:creationId xmlns:a16="http://schemas.microsoft.com/office/drawing/2014/main" id="{415E1526-D471-4458-8434-B6B3618243E0}"/>
+                <a16:creationId xmlns:a16="http://schemas.microsoft.com/office/drawing/2014/main" id="{394886A2-C4E8-42A5-A6D5-DC7E88937944}"/>
               </a:ext>
             </a:extLst>
           </p:cNvPr>
@@ -5607,7 +5607,7 @@
           <p:cNvPr id="9" name="">
             <a:extLst xmlns:a="http://schemas.openxmlformats.org/drawingml/2006/main">
               <a:ext uri="{FF2B5EF4-FFF2-40B4-BE49-F238E27FC236}">
-                <a16:creationId xmlns:a16="http://schemas.microsoft.com/office/drawing/2014/main" id="{1A0F46C3-F515-457D-84A2-46A1967BDD5A}"/>
+                <a16:creationId xmlns:a16="http://schemas.microsoft.com/office/drawing/2014/main" id="{D2C5D5C5-C209-4522-A5E1-57560941EE71}"/>
               </a:ext>
             </a:extLst>
           </p:cNvPr>
@@ -5687,7 +5687,7 @@
           <p:cNvPr id="10" name="">
             <a:extLst xmlns:a="http://schemas.openxmlformats.org/drawingml/2006/main">
               <a:ext uri="{FF2B5EF4-FFF2-40B4-BE49-F238E27FC236}">
-                <a16:creationId xmlns:a16="http://schemas.microsoft.com/office/drawing/2014/main" id="{BF4FF3EF-9B22-4E08-B4C5-80329B532A6B}"/>
+                <a16:creationId xmlns:a16="http://schemas.microsoft.com/office/drawing/2014/main" id="{645E2763-CA66-4083-9A97-28C8AEBF0488}"/>
               </a:ext>
             </a:extLst>
           </p:cNvPr>
@@ -5742,7 +5742,7 @@
     </p:spTree>
     <p:extLst>
       <p:ext uri="{BB962C8B-B14F-4D97-AF65-F5344CB8AC3E}">
-        <p14:creationId xmlns:p14="http://schemas.microsoft.com/office/powerpoint/2010/main" val="1117834984"/>
+        <p14:creationId xmlns:p14="http://schemas.microsoft.com/office/powerpoint/2010/main" val="449671395"/>
       </p:ext>
     </p:extLst>
   </p:cSld>
@@ -5773,7 +5773,7 @@
           <p:cNvPr id="10" name="">
             <a:extLst xmlns:a="http://schemas.openxmlformats.org/drawingml/2006/main">
               <a:ext uri="{FF2B5EF4-FFF2-40B4-BE49-F238E27FC236}">
-                <a16:creationId xmlns:a16="http://schemas.microsoft.com/office/drawing/2014/main" id="{08E05A19-F520-495F-92C7-003576210263}"/>
+                <a16:creationId xmlns:a16="http://schemas.microsoft.com/office/drawing/2014/main" id="{944DC655-6C06-48BF-985B-45799D87C2DA}"/>
               </a:ext>
             </a:extLst>
           </p:cNvPr>
@@ -5830,7 +5830,7 @@
           <p:cNvPr id="2" name="">
             <a:extLst xmlns:a="http://schemas.openxmlformats.org/drawingml/2006/main">
               <a:ext uri="{FF2B5EF4-FFF2-40B4-BE49-F238E27FC236}">
-                <a16:creationId xmlns:a16="http://schemas.microsoft.com/office/drawing/2014/main" id="{EEBD48D1-7549-486C-8651-4C6DCB8AF4A3}"/>
+                <a16:creationId xmlns:a16="http://schemas.microsoft.com/office/drawing/2014/main" id="{2EF77416-3BFE-4905-A6E4-6E6DBEE17BC3}"/>
               </a:ext>
             </a:extLst>
           </p:cNvPr>
@@ -5887,7 +5887,7 @@
           <p:cNvPr id="3" name="">
             <a:extLst xmlns:a="http://schemas.openxmlformats.org/drawingml/2006/main">
               <a:ext uri="{FF2B5EF4-FFF2-40B4-BE49-F238E27FC236}">
-                <a16:creationId xmlns:a16="http://schemas.microsoft.com/office/drawing/2014/main" id="{FB102FC8-AC9F-4686-92E8-39FC8C9828FD}"/>
+                <a16:creationId xmlns:a16="http://schemas.microsoft.com/office/drawing/2014/main" id="{A341CD29-669C-48CD-94F3-016F4C7C3F58}"/>
               </a:ext>
             </a:extLst>
           </p:cNvPr>
@@ -5944,7 +5944,7 @@
           <p:cNvPr id="4" name="">
             <a:extLst xmlns:a="http://schemas.openxmlformats.org/drawingml/2006/main">
               <a:ext uri="{FF2B5EF4-FFF2-40B4-BE49-F238E27FC236}">
-                <a16:creationId xmlns:a16="http://schemas.microsoft.com/office/drawing/2014/main" id="{CB6912EC-7BE3-4774-B478-39DEDCF10D18}"/>
+                <a16:creationId xmlns:a16="http://schemas.microsoft.com/office/drawing/2014/main" id="{DD531819-26EF-4ADD-8BAB-595C8C921D14}"/>
               </a:ext>
             </a:extLst>
           </p:cNvPr>
@@ -6001,7 +6001,7 @@
           <p:cNvPr id="5" name="">
             <a:extLst xmlns:a="http://schemas.openxmlformats.org/drawingml/2006/main">
               <a:ext uri="{FF2B5EF4-FFF2-40B4-BE49-F238E27FC236}">
-                <a16:creationId xmlns:a16="http://schemas.microsoft.com/office/drawing/2014/main" id="{DBB5212F-A401-4247-8A09-86A653409BF2}"/>
+                <a16:creationId xmlns:a16="http://schemas.microsoft.com/office/drawing/2014/main" id="{74920B02-D2E4-476C-B475-14AA977E59D0}"/>
               </a:ext>
             </a:extLst>
           </p:cNvPr>
@@ -6058,7 +6058,7 @@
           <p:cNvPr id="6" name="">
             <a:extLst xmlns:a="http://schemas.openxmlformats.org/drawingml/2006/main">
               <a:ext uri="{FF2B5EF4-FFF2-40B4-BE49-F238E27FC236}">
-                <a16:creationId xmlns:a16="http://schemas.microsoft.com/office/drawing/2014/main" id="{8780E64D-AB20-49D4-9DCF-51047B5F5C1D}"/>
+                <a16:creationId xmlns:a16="http://schemas.microsoft.com/office/drawing/2014/main" id="{808B1DDE-A80D-4FB9-BF81-C2136B4D3735}"/>
               </a:ext>
             </a:extLst>
           </p:cNvPr>
@@ -6253,7 +6253,7 @@
           <p:cNvPr id="7" name="">
             <a:extLst xmlns:a="http://schemas.openxmlformats.org/drawingml/2006/main">
               <a:ext uri="{FF2B5EF4-FFF2-40B4-BE49-F238E27FC236}">
-                <a16:creationId xmlns:a16="http://schemas.microsoft.com/office/drawing/2014/main" id="{70849157-B7EF-4FDF-96EA-6E674AA09442}"/>
+                <a16:creationId xmlns:a16="http://schemas.microsoft.com/office/drawing/2014/main" id="{70162748-2697-44B7-83D1-C10F50E353F5}"/>
               </a:ext>
             </a:extLst>
           </p:cNvPr>
@@ -6300,7 +6300,7 @@
                 <a:ea typeface="Menlo"/>
                 <a:cs typeface="Menlo"/>
               </a:rPr>
-              <a:t>const payment = {</a:t>
+              <a:t>await client.submitAndWait({</a:t>
             </a:r>
           </a:p>
           <a:p xmlns:a="http://schemas.openxmlformats.org/drawingml/2006/main">
@@ -6369,7 +6369,7 @@
                 <a:ea typeface="Menlo"/>
                 <a:cs typeface="Menlo"/>
               </a:rPr>
-              <a:t>  Destination: receiver.address,</a:t>
+              <a:t>  Destination: to.address,</a:t>
             </a:r>
           </a:p>
           <a:p xmlns:a="http://schemas.openxmlformats.org/drawingml/2006/main">
@@ -6438,7 +6438,7 @@
                 <a:ea typeface="Menlo"/>
                 <a:cs typeface="Menlo"/>
               </a:rPr>
-              <a:t>} satisfies Payment</a:t>
+              <a:t>}, { wallet: sender })</a:t>
             </a:r>
           </a:p>
         </p:txBody>
@@ -6448,7 +6448,7 @@
           <p:cNvPr id="8" name="">
             <a:extLst xmlns:a="http://schemas.openxmlformats.org/drawingml/2006/main">
               <a:ext uri="{FF2B5EF4-FFF2-40B4-BE49-F238E27FC236}">
-                <a16:creationId xmlns:a16="http://schemas.microsoft.com/office/drawing/2014/main" id="{693F540D-7F0B-4FDC-8830-69666BDED072}"/>
+                <a16:creationId xmlns:a16="http://schemas.microsoft.com/office/drawing/2014/main" id="{9C946C5F-4609-4220-88AB-4B35C5D1351E}"/>
               </a:ext>
             </a:extLst>
           </p:cNvPr>
@@ -6528,7 +6528,7 @@
           <p:cNvPr id="9" name="">
             <a:extLst xmlns:a="http://schemas.openxmlformats.org/drawingml/2006/main">
               <a:ext uri="{FF2B5EF4-FFF2-40B4-BE49-F238E27FC236}">
-                <a16:creationId xmlns:a16="http://schemas.microsoft.com/office/drawing/2014/main" id="{9CF3CDE5-6329-422A-9BB5-44ADA5F77375}"/>
+                <a16:creationId xmlns:a16="http://schemas.microsoft.com/office/drawing/2014/main" id="{28498971-ADE3-430B-BF06-4B0F5EB58FB6}"/>
               </a:ext>
             </a:extLst>
           </p:cNvPr>
@@ -6575,7 +6575,7 @@
                 <a:ea typeface="Helvetica Neue"/>
                 <a:cs typeface="Helvetica Neue"/>
               </a:rPr>
-              <a:t>Rejected at the draft.</a:t>
+              <a:t>Payment guides the fields.</a:t>
             </a:r>
           </a:p>
           <a:p xmlns:a="http://schemas.openxmlformats.org/drawingml/2006/main">
@@ -6598,7 +6598,7 @@
                 <a:ea typeface="Helvetica Neue"/>
                 <a:cs typeface="Helvetica Neue"/>
               </a:rPr>
-              <a:t>Did you mean DestinationTag?</a:t>
+              <a:t>The typo is rejected at the call.</a:t>
             </a:r>
           </a:p>
         </p:txBody>
@@ -6606,7 +6606,7 @@
     </p:spTree>
     <p:extLst>
       <p:ext uri="{BB962C8B-B14F-4D97-AF65-F5344CB8AC3E}">
-        <p14:creationId xmlns:p14="http://schemas.microsoft.com/office/powerpoint/2010/main" val="971182714"/>
+        <p14:creationId xmlns:p14="http://schemas.microsoft.com/office/powerpoint/2010/main" val="27003501"/>
       </p:ext>
     </p:extLst>
   </p:cSld>
@@ -6637,7 +6637,7 @@
           <p:cNvPr id="10" name="">
             <a:extLst xmlns:a="http://schemas.openxmlformats.org/drawingml/2006/main">
               <a:ext uri="{FF2B5EF4-FFF2-40B4-BE49-F238E27FC236}">
-                <a16:creationId xmlns:a16="http://schemas.microsoft.com/office/drawing/2014/main" id="{7AE52A9F-C3F1-4A9C-9212-12717731A62B}"/>
+                <a16:creationId xmlns:a16="http://schemas.microsoft.com/office/drawing/2014/main" id="{27343491-1F9F-4154-B651-354F1B886D8C}"/>
               </a:ext>
             </a:extLst>
           </p:cNvPr>
@@ -6694,7 +6694,7 @@
           <p:cNvPr id="2" name="">
             <a:extLst xmlns:a="http://schemas.openxmlformats.org/drawingml/2006/main">
               <a:ext uri="{FF2B5EF4-FFF2-40B4-BE49-F238E27FC236}">
-                <a16:creationId xmlns:a16="http://schemas.microsoft.com/office/drawing/2014/main" id="{B4B58655-D849-42FB-8C96-711C7FBF48F5}"/>
+                <a16:creationId xmlns:a16="http://schemas.microsoft.com/office/drawing/2014/main" id="{E7C0D3B9-9DEF-4C7E-8B76-32C7128F854E}"/>
               </a:ext>
             </a:extLst>
           </p:cNvPr>
@@ -6751,7 +6751,7 @@
           <p:cNvPr id="3" name="">
             <a:extLst xmlns:a="http://schemas.openxmlformats.org/drawingml/2006/main">
               <a:ext uri="{FF2B5EF4-FFF2-40B4-BE49-F238E27FC236}">
-                <a16:creationId xmlns:a16="http://schemas.microsoft.com/office/drawing/2014/main" id="{EA4B3C18-C6CB-4BB8-B5AF-4C54D5186FB1}"/>
+                <a16:creationId xmlns:a16="http://schemas.microsoft.com/office/drawing/2014/main" id="{605E21C7-73C1-43C5-A844-93E3BA7661AB}"/>
               </a:ext>
             </a:extLst>
           </p:cNvPr>
@@ -6808,7 +6808,7 @@
           <p:cNvPr id="4" name="">
             <a:extLst xmlns:a="http://schemas.openxmlformats.org/drawingml/2006/main">
               <a:ext uri="{FF2B5EF4-FFF2-40B4-BE49-F238E27FC236}">
-                <a16:creationId xmlns:a16="http://schemas.microsoft.com/office/drawing/2014/main" id="{102AE488-763A-4057-9EC4-5954D20E1AC2}"/>
+                <a16:creationId xmlns:a16="http://schemas.microsoft.com/office/drawing/2014/main" id="{4E0818FD-EB4F-4A9E-A0D4-C88A7A31EAE2}"/>
               </a:ext>
             </a:extLst>
           </p:cNvPr>
@@ -6865,7 +6865,7 @@
           <p:cNvPr id="5" name="">
             <a:extLst xmlns:a="http://schemas.openxmlformats.org/drawingml/2006/main">
               <a:ext uri="{FF2B5EF4-FFF2-40B4-BE49-F238E27FC236}">
-                <a16:creationId xmlns:a16="http://schemas.microsoft.com/office/drawing/2014/main" id="{80330693-1EBD-44C5-8F08-D85896900A70}"/>
+                <a16:creationId xmlns:a16="http://schemas.microsoft.com/office/drawing/2014/main" id="{F4D63050-B3FA-4902-B65E-52612E532244}"/>
               </a:ext>
             </a:extLst>
           </p:cNvPr>
@@ -6922,7 +6922,7 @@
           <p:cNvPr id="6" name="">
             <a:extLst xmlns:a="http://schemas.openxmlformats.org/drawingml/2006/main">
               <a:ext uri="{FF2B5EF4-FFF2-40B4-BE49-F238E27FC236}">
-                <a16:creationId xmlns:a16="http://schemas.microsoft.com/office/drawing/2014/main" id="{0119BFDD-9D51-4B2D-8D55-326B021F2564}"/>
+                <a16:creationId xmlns:a16="http://schemas.microsoft.com/office/drawing/2014/main" id="{C3C52E27-4944-4970-9104-233FDF76D101}"/>
               </a:ext>
             </a:extLst>
           </p:cNvPr>
@@ -7094,7 +7094,7 @@
           <p:cNvPr id="7" name="">
             <a:extLst xmlns:a="http://schemas.openxmlformats.org/drawingml/2006/main">
               <a:ext uri="{FF2B5EF4-FFF2-40B4-BE49-F238E27FC236}">
-                <a16:creationId xmlns:a16="http://schemas.microsoft.com/office/drawing/2014/main" id="{809237D4-FA3C-41B8-8FA3-8BC1CC406A67}"/>
+                <a16:creationId xmlns:a16="http://schemas.microsoft.com/office/drawing/2014/main" id="{2C43DF2D-1C3C-4805-986A-0DB629B83E61}"/>
               </a:ext>
             </a:extLst>
           </p:cNvPr>
@@ -7266,7 +7266,7 @@
           <p:cNvPr id="8" name="">
             <a:extLst xmlns:a="http://schemas.openxmlformats.org/drawingml/2006/main">
               <a:ext uri="{FF2B5EF4-FFF2-40B4-BE49-F238E27FC236}">
-                <a16:creationId xmlns:a16="http://schemas.microsoft.com/office/drawing/2014/main" id="{62B3C6C0-0277-4B42-AA22-C7F7E27C6680}"/>
+                <a16:creationId xmlns:a16="http://schemas.microsoft.com/office/drawing/2014/main" id="{5C1EA8D6-5923-4B91-B27B-68A62EFB7D37}"/>
               </a:ext>
             </a:extLst>
           </p:cNvPr>
@@ -7346,7 +7346,7 @@
           <p:cNvPr id="9" name="">
             <a:extLst xmlns:a="http://schemas.openxmlformats.org/drawingml/2006/main">
               <a:ext uri="{FF2B5EF4-FFF2-40B4-BE49-F238E27FC236}">
-                <a16:creationId xmlns:a16="http://schemas.microsoft.com/office/drawing/2014/main" id="{BD54BB9F-B1ED-4DCE-9C73-3EF3027DD680}"/>
+                <a16:creationId xmlns:a16="http://schemas.microsoft.com/office/drawing/2014/main" id="{436937EA-AAA8-4A0D-9D77-87B6F88BFA9A}"/>
               </a:ext>
             </a:extLst>
           </p:cNvPr>
@@ -7424,7 +7424,7 @@
     </p:spTree>
     <p:extLst>
       <p:ext uri="{BB962C8B-B14F-4D97-AF65-F5344CB8AC3E}">
-        <p14:creationId xmlns:p14="http://schemas.microsoft.com/office/powerpoint/2010/main" val="1051070603"/>
+        <p14:creationId xmlns:p14="http://schemas.microsoft.com/office/powerpoint/2010/main" val="48079667"/>
       </p:ext>
     </p:extLst>
   </p:cSld>
@@ -7455,7 +7455,7 @@
           <p:cNvPr id="10" name="">
             <a:extLst xmlns:a="http://schemas.openxmlformats.org/drawingml/2006/main">
               <a:ext uri="{FF2B5EF4-FFF2-40B4-BE49-F238E27FC236}">
-                <a16:creationId xmlns:a16="http://schemas.microsoft.com/office/drawing/2014/main" id="{19332DAE-A334-42CE-9E71-169CA5814D57}"/>
+                <a16:creationId xmlns:a16="http://schemas.microsoft.com/office/drawing/2014/main" id="{08BA2A90-A43D-4836-A066-C77437FCF5BA}"/>
               </a:ext>
             </a:extLst>
           </p:cNvPr>
@@ -7512,7 +7512,7 @@
           <p:cNvPr id="2" name="">
             <a:extLst xmlns:a="http://schemas.openxmlformats.org/drawingml/2006/main">
               <a:ext uri="{FF2B5EF4-FFF2-40B4-BE49-F238E27FC236}">
-                <a16:creationId xmlns:a16="http://schemas.microsoft.com/office/drawing/2014/main" id="{E61C56CF-65B6-4172-9944-9BC8D837E42F}"/>
+                <a16:creationId xmlns:a16="http://schemas.microsoft.com/office/drawing/2014/main" id="{25A3D771-20A0-4C37-A710-D1CA111E67AF}"/>
               </a:ext>
             </a:extLst>
           </p:cNvPr>
@@ -7569,7 +7569,7 @@
           <p:cNvPr id="3" name="">
             <a:extLst xmlns:a="http://schemas.openxmlformats.org/drawingml/2006/main">
               <a:ext uri="{FF2B5EF4-FFF2-40B4-BE49-F238E27FC236}">
-                <a16:creationId xmlns:a16="http://schemas.microsoft.com/office/drawing/2014/main" id="{01610D97-AE2E-4E6B-923F-96C303565D15}"/>
+                <a16:creationId xmlns:a16="http://schemas.microsoft.com/office/drawing/2014/main" id="{1C363CEF-D626-4132-891D-FA65B289B953}"/>
               </a:ext>
             </a:extLst>
           </p:cNvPr>
@@ -7626,7 +7626,7 @@
           <p:cNvPr id="4" name="">
             <a:extLst xmlns:a="http://schemas.openxmlformats.org/drawingml/2006/main">
               <a:ext uri="{FF2B5EF4-FFF2-40B4-BE49-F238E27FC236}">
-                <a16:creationId xmlns:a16="http://schemas.microsoft.com/office/drawing/2014/main" id="{9BF11E4A-ACC9-43ED-8C7A-B46D8D6C810D}"/>
+                <a16:creationId xmlns:a16="http://schemas.microsoft.com/office/drawing/2014/main" id="{1919EC6B-26DD-4437-A453-8E456B8456FE}"/>
               </a:ext>
             </a:extLst>
           </p:cNvPr>
@@ -7683,7 +7683,7 @@
           <p:cNvPr id="5" name="">
             <a:extLst xmlns:a="http://schemas.openxmlformats.org/drawingml/2006/main">
               <a:ext uri="{FF2B5EF4-FFF2-40B4-BE49-F238E27FC236}">
-                <a16:creationId xmlns:a16="http://schemas.microsoft.com/office/drawing/2014/main" id="{7EE7898A-A6B5-4FF3-A039-56BDFF40FD87}"/>
+                <a16:creationId xmlns:a16="http://schemas.microsoft.com/office/drawing/2014/main" id="{D2C6FFC9-A4E4-4CEC-A012-E2C574983BAE}"/>
               </a:ext>
             </a:extLst>
           </p:cNvPr>
@@ -7740,7 +7740,7 @@
           <p:cNvPr id="6" name="">
             <a:extLst xmlns:a="http://schemas.openxmlformats.org/drawingml/2006/main">
               <a:ext uri="{FF2B5EF4-FFF2-40B4-BE49-F238E27FC236}">
-                <a16:creationId xmlns:a16="http://schemas.microsoft.com/office/drawing/2014/main" id="{FE109A70-2BE0-4372-99D7-EEC4E65D0FC0}"/>
+                <a16:creationId xmlns:a16="http://schemas.microsoft.com/office/drawing/2014/main" id="{8A5C4F3D-60BF-4A18-BF63-587CF17DD936}"/>
               </a:ext>
             </a:extLst>
           </p:cNvPr>
@@ -7889,7 +7889,7 @@
           <p:cNvPr id="7" name="">
             <a:extLst xmlns:a="http://schemas.openxmlformats.org/drawingml/2006/main">
               <a:ext uri="{FF2B5EF4-FFF2-40B4-BE49-F238E27FC236}">
-                <a16:creationId xmlns:a16="http://schemas.microsoft.com/office/drawing/2014/main" id="{5FA01B06-79F4-4009-A044-BE03C79E11AA}"/>
+                <a16:creationId xmlns:a16="http://schemas.microsoft.com/office/drawing/2014/main" id="{A8E721CF-9CB6-4FA2-BFF5-64218B2EAC1E}"/>
               </a:ext>
             </a:extLst>
           </p:cNvPr>
@@ -8038,7 +8038,7 @@
           <p:cNvPr id="8" name="">
             <a:extLst xmlns:a="http://schemas.openxmlformats.org/drawingml/2006/main">
               <a:ext uri="{FF2B5EF4-FFF2-40B4-BE49-F238E27FC236}">
-                <a16:creationId xmlns:a16="http://schemas.microsoft.com/office/drawing/2014/main" id="{0FD4C8A1-68E0-46CC-945D-1BF005C026D3}"/>
+                <a16:creationId xmlns:a16="http://schemas.microsoft.com/office/drawing/2014/main" id="{837D4E27-3003-4974-B5B4-6263ECD6C905}"/>
               </a:ext>
             </a:extLst>
           </p:cNvPr>
@@ -8118,7 +8118,7 @@
           <p:cNvPr id="9" name="">
             <a:extLst xmlns:a="http://schemas.openxmlformats.org/drawingml/2006/main">
               <a:ext uri="{FF2B5EF4-FFF2-40B4-BE49-F238E27FC236}">
-                <a16:creationId xmlns:a16="http://schemas.microsoft.com/office/drawing/2014/main" id="{F34B8968-E88C-455F-9A56-21C90F4CF81E}"/>
+                <a16:creationId xmlns:a16="http://schemas.microsoft.com/office/drawing/2014/main" id="{D1521D29-4663-49FD-87F1-33E245085591}"/>
               </a:ext>
             </a:extLst>
           </p:cNvPr>
@@ -8196,7 +8196,7 @@
     </p:spTree>
     <p:extLst>
       <p:ext uri="{BB962C8B-B14F-4D97-AF65-F5344CB8AC3E}">
-        <p14:creationId xmlns:p14="http://schemas.microsoft.com/office/powerpoint/2010/main" val="2026503934"/>
+        <p14:creationId xmlns:p14="http://schemas.microsoft.com/office/powerpoint/2010/main" val="1990152426"/>
       </p:ext>
     </p:extLst>
   </p:cSld>
@@ -8227,7 +8227,7 @@
           <p:cNvPr id="10" name="">
             <a:extLst xmlns:a="http://schemas.openxmlformats.org/drawingml/2006/main">
               <a:ext uri="{FF2B5EF4-FFF2-40B4-BE49-F238E27FC236}">
-                <a16:creationId xmlns:a16="http://schemas.microsoft.com/office/drawing/2014/main" id="{0B86B8A4-7B08-4737-AE99-D6A06CFD8FB8}"/>
+                <a16:creationId xmlns:a16="http://schemas.microsoft.com/office/drawing/2014/main" id="{897CD95F-D2DE-4048-8F82-0E56A756A52F}"/>
               </a:ext>
             </a:extLst>
           </p:cNvPr>
@@ -8284,7 +8284,7 @@
           <p:cNvPr id="2" name="">
             <a:extLst xmlns:a="http://schemas.openxmlformats.org/drawingml/2006/main">
               <a:ext uri="{FF2B5EF4-FFF2-40B4-BE49-F238E27FC236}">
-                <a16:creationId xmlns:a16="http://schemas.microsoft.com/office/drawing/2014/main" id="{3E813C65-5351-4617-8F1B-0EEFA645B55A}"/>
+                <a16:creationId xmlns:a16="http://schemas.microsoft.com/office/drawing/2014/main" id="{FD8231D5-43B6-4A5A-9745-C45F64843FD6}"/>
               </a:ext>
             </a:extLst>
           </p:cNvPr>
@@ -8341,7 +8341,7 @@
           <p:cNvPr id="3" name="">
             <a:extLst xmlns:a="http://schemas.openxmlformats.org/drawingml/2006/main">
               <a:ext uri="{FF2B5EF4-FFF2-40B4-BE49-F238E27FC236}">
-                <a16:creationId xmlns:a16="http://schemas.microsoft.com/office/drawing/2014/main" id="{AE04C753-FBB3-4CF1-8D12-B889805C78CD}"/>
+                <a16:creationId xmlns:a16="http://schemas.microsoft.com/office/drawing/2014/main" id="{4C74D134-256D-4DCE-AE45-D42662B69065}"/>
               </a:ext>
             </a:extLst>
           </p:cNvPr>
@@ -8398,7 +8398,7 @@
           <p:cNvPr id="4" name="">
             <a:extLst xmlns:a="http://schemas.openxmlformats.org/drawingml/2006/main">
               <a:ext uri="{FF2B5EF4-FFF2-40B4-BE49-F238E27FC236}">
-                <a16:creationId xmlns:a16="http://schemas.microsoft.com/office/drawing/2014/main" id="{AAECF52D-FDE8-4BBB-B25B-F08C994D4550}"/>
+                <a16:creationId xmlns:a16="http://schemas.microsoft.com/office/drawing/2014/main" id="{22D8C996-795F-45EF-8851-2A5B2DC92910}"/>
               </a:ext>
             </a:extLst>
           </p:cNvPr>
@@ -8455,7 +8455,7 @@
           <p:cNvPr id="5" name="">
             <a:extLst xmlns:a="http://schemas.openxmlformats.org/drawingml/2006/main">
               <a:ext uri="{FF2B5EF4-FFF2-40B4-BE49-F238E27FC236}">
-                <a16:creationId xmlns:a16="http://schemas.microsoft.com/office/drawing/2014/main" id="{60D7048B-71AC-4CCF-9663-794B80703D0B}"/>
+                <a16:creationId xmlns:a16="http://schemas.microsoft.com/office/drawing/2014/main" id="{286E1756-7C6C-487F-B650-69899F93EB27}"/>
               </a:ext>
             </a:extLst>
           </p:cNvPr>
@@ -8512,7 +8512,7 @@
           <p:cNvPr id="6" name="">
             <a:extLst xmlns:a="http://schemas.openxmlformats.org/drawingml/2006/main">
               <a:ext uri="{FF2B5EF4-FFF2-40B4-BE49-F238E27FC236}">
-                <a16:creationId xmlns:a16="http://schemas.microsoft.com/office/drawing/2014/main" id="{A33B8AA8-76F8-4BA2-889A-52206015CC71}"/>
+                <a16:creationId xmlns:a16="http://schemas.microsoft.com/office/drawing/2014/main" id="{EFC072F2-BC79-43A1-8214-A2587FAF784C}"/>
               </a:ext>
             </a:extLst>
           </p:cNvPr>
@@ -8707,7 +8707,7 @@
           <p:cNvPr id="7" name="">
             <a:extLst xmlns:a="http://schemas.openxmlformats.org/drawingml/2006/main">
               <a:ext uri="{FF2B5EF4-FFF2-40B4-BE49-F238E27FC236}">
-                <a16:creationId xmlns:a16="http://schemas.microsoft.com/office/drawing/2014/main" id="{B9CF448C-8BCB-4F03-B3E8-4C00AE51C4BC}"/>
+                <a16:creationId xmlns:a16="http://schemas.microsoft.com/office/drawing/2014/main" id="{D4985832-1CC0-4252-9ABC-3F0FC17BBF46}"/>
               </a:ext>
             </a:extLst>
           </p:cNvPr>
@@ -8833,7 +8833,7 @@
           <p:cNvPr id="8" name="">
             <a:extLst xmlns:a="http://schemas.openxmlformats.org/drawingml/2006/main">
               <a:ext uri="{FF2B5EF4-FFF2-40B4-BE49-F238E27FC236}">
-                <a16:creationId xmlns:a16="http://schemas.microsoft.com/office/drawing/2014/main" id="{C403FA8D-30DA-458E-B9A5-3B017805B5DF}"/>
+                <a16:creationId xmlns:a16="http://schemas.microsoft.com/office/drawing/2014/main" id="{16D2D0BD-BFE6-4339-8955-6725CC525392}"/>
               </a:ext>
             </a:extLst>
           </p:cNvPr>
@@ -8913,7 +8913,7 @@
           <p:cNvPr id="9" name="">
             <a:extLst xmlns:a="http://schemas.openxmlformats.org/drawingml/2006/main">
               <a:ext uri="{FF2B5EF4-FFF2-40B4-BE49-F238E27FC236}">
-                <a16:creationId xmlns:a16="http://schemas.microsoft.com/office/drawing/2014/main" id="{467DFA9D-06AD-4B79-A003-EBBCD77834BC}"/>
+                <a16:creationId xmlns:a16="http://schemas.microsoft.com/office/drawing/2014/main" id="{F490F73E-A434-4F6F-BD55-FAE8EFEE3C50}"/>
               </a:ext>
             </a:extLst>
           </p:cNvPr>
@@ -8991,7 +8991,7 @@
     </p:spTree>
     <p:extLst>
       <p:ext uri="{BB962C8B-B14F-4D97-AF65-F5344CB8AC3E}">
-        <p14:creationId xmlns:p14="http://schemas.microsoft.com/office/powerpoint/2010/main" val="764627927"/>
+        <p14:creationId xmlns:p14="http://schemas.microsoft.com/office/powerpoint/2010/main" val="67639008"/>
       </p:ext>
     </p:extLst>
   </p:cSld>
@@ -9022,7 +9022,7 @@
           <p:cNvPr id="13" name="">
             <a:extLst xmlns:a="http://schemas.openxmlformats.org/drawingml/2006/main">
               <a:ext uri="{FF2B5EF4-FFF2-40B4-BE49-F238E27FC236}">
-                <a16:creationId xmlns:a16="http://schemas.microsoft.com/office/drawing/2014/main" id="{8DA144CD-B8B9-4E46-B330-709E08D1645B}"/>
+                <a16:creationId xmlns:a16="http://schemas.microsoft.com/office/drawing/2014/main" id="{9F6E6B16-7892-4647-8DD4-8C6F22B6A9A2}"/>
               </a:ext>
             </a:extLst>
           </p:cNvPr>
@@ -9079,7 +9079,7 @@
           <p:cNvPr id="2" name="">
             <a:extLst xmlns:a="http://schemas.openxmlformats.org/drawingml/2006/main">
               <a:ext uri="{FF2B5EF4-FFF2-40B4-BE49-F238E27FC236}">
-                <a16:creationId xmlns:a16="http://schemas.microsoft.com/office/drawing/2014/main" id="{67B32554-0973-4283-859D-EB09881F065A}"/>
+                <a16:creationId xmlns:a16="http://schemas.microsoft.com/office/drawing/2014/main" id="{76D03C46-CA82-4C59-B28D-73D32BCF16C9}"/>
               </a:ext>
             </a:extLst>
           </p:cNvPr>
@@ -9136,7 +9136,7 @@
           <p:cNvPr id="3" name="">
             <a:extLst xmlns:a="http://schemas.openxmlformats.org/drawingml/2006/main">
               <a:ext uri="{FF2B5EF4-FFF2-40B4-BE49-F238E27FC236}">
-                <a16:creationId xmlns:a16="http://schemas.microsoft.com/office/drawing/2014/main" id="{775A7A4F-7D52-46CC-AF1B-2CA8C4A7BF53}"/>
+                <a16:creationId xmlns:a16="http://schemas.microsoft.com/office/drawing/2014/main" id="{BB27AE1D-2936-4C66-B4B5-0782A5ADB289}"/>
               </a:ext>
             </a:extLst>
           </p:cNvPr>
@@ -9193,7 +9193,7 @@
           <p:cNvPr id="4" name="">
             <a:extLst xmlns:a="http://schemas.openxmlformats.org/drawingml/2006/main">
               <a:ext uri="{FF2B5EF4-FFF2-40B4-BE49-F238E27FC236}">
-                <a16:creationId xmlns:a16="http://schemas.microsoft.com/office/drawing/2014/main" id="{C55204EF-999B-4E73-B8EF-8B1DEF620026}"/>
+                <a16:creationId xmlns:a16="http://schemas.microsoft.com/office/drawing/2014/main" id="{94AD1A3B-3A19-46EF-AEF5-F41125E4AA73}"/>
               </a:ext>
             </a:extLst>
           </p:cNvPr>
@@ -9250,7 +9250,7 @@
           <p:cNvPr id="5" name="">
             <a:extLst xmlns:a="http://schemas.openxmlformats.org/drawingml/2006/main">
               <a:ext uri="{FF2B5EF4-FFF2-40B4-BE49-F238E27FC236}">
-                <a16:creationId xmlns:a16="http://schemas.microsoft.com/office/drawing/2014/main" id="{B8EF7118-0405-40BB-9326-CA4642789274}"/>
+                <a16:creationId xmlns:a16="http://schemas.microsoft.com/office/drawing/2014/main" id="{419076F5-F783-4C95-9EAA-83941C99C42F}"/>
               </a:ext>
             </a:extLst>
           </p:cNvPr>
@@ -9297,7 +9297,7 @@
                 <a:ea typeface="Helvetica Neue"/>
                 <a:cs typeface="Helvetica Neue"/>
               </a:rPr>
-              <a:t>Input guidance, inferred replies and checked outcomes</a:t>
+              <a:t>Inline fields, inferred replies and checked outcomes</a:t>
             </a:r>
           </a:p>
         </p:txBody>
@@ -9307,7 +9307,7 @@
           <p:cNvPr id="6" name="">
             <a:extLst xmlns:a="http://schemas.openxmlformats.org/drawingml/2006/main">
               <a:ext uri="{FF2B5EF4-FFF2-40B4-BE49-F238E27FC236}">
-                <a16:creationId xmlns:a16="http://schemas.microsoft.com/office/drawing/2014/main" id="{811DEA9A-EC5A-4039-9614-047DA05B64BB}"/>
+                <a16:creationId xmlns:a16="http://schemas.microsoft.com/office/drawing/2014/main" id="{BA31B33D-6054-4941-9AA1-C38A10D50B1C}"/>
               </a:ext>
             </a:extLst>
           </p:cNvPr>
@@ -9364,7 +9364,7 @@
           <p:cNvPr id="7" name="">
             <a:extLst xmlns:a="http://schemas.openxmlformats.org/drawingml/2006/main">
               <a:ext uri="{FF2B5EF4-FFF2-40B4-BE49-F238E27FC236}">
-                <a16:creationId xmlns:a16="http://schemas.microsoft.com/office/drawing/2014/main" id="{3DAEF2F9-8466-4CA0-BE99-13B0AE87FC12}"/>
+                <a16:creationId xmlns:a16="http://schemas.microsoft.com/office/drawing/2014/main" id="{8D21AD98-AD59-4996-88D9-6AE14F8F8948}"/>
               </a:ext>
             </a:extLst>
           </p:cNvPr>
@@ -9421,7 +9421,7 @@
           <p:cNvPr id="8" name="">
             <a:extLst xmlns:a="http://schemas.openxmlformats.org/drawingml/2006/main">
               <a:ext uri="{FF2B5EF4-FFF2-40B4-BE49-F238E27FC236}">
-                <a16:creationId xmlns:a16="http://schemas.microsoft.com/office/drawing/2014/main" id="{341EBA9E-25AB-4A94-9179-367DA36B5461}"/>
+                <a16:creationId xmlns:a16="http://schemas.microsoft.com/office/drawing/2014/main" id="{76655B5F-6111-465A-BB5C-8C5DB53A150A}"/>
               </a:ext>
             </a:extLst>
           </p:cNvPr>
@@ -9478,7 +9478,7 @@
           <p:cNvPr id="9" name="">
             <a:extLst xmlns:a="http://schemas.openxmlformats.org/drawingml/2006/main">
               <a:ext uri="{FF2B5EF4-FFF2-40B4-BE49-F238E27FC236}">
-                <a16:creationId xmlns:a16="http://schemas.microsoft.com/office/drawing/2014/main" id="{DB02D375-1F1F-4676-8BCC-7B280032BCC9}"/>
+                <a16:creationId xmlns:a16="http://schemas.microsoft.com/office/drawing/2014/main" id="{DF80CFC8-7123-47C4-B7D0-3961F886DEA0}"/>
               </a:ext>
             </a:extLst>
           </p:cNvPr>
@@ -9535,7 +9535,7 @@
           <p:cNvPr id="10" name="">
             <a:extLst xmlns:a="http://schemas.openxmlformats.org/drawingml/2006/main">
               <a:ext uri="{FF2B5EF4-FFF2-40B4-BE49-F238E27FC236}">
-                <a16:creationId xmlns:a16="http://schemas.microsoft.com/office/drawing/2014/main" id="{C2659978-3C70-4266-BC73-0DC18B1BCAB0}"/>
+                <a16:creationId xmlns:a16="http://schemas.microsoft.com/office/drawing/2014/main" id="{29CBCED1-3215-47D6-A10D-A5F2CBEE5454}"/>
               </a:ext>
             </a:extLst>
           </p:cNvPr>
@@ -9592,7 +9592,7 @@
           <p:cNvPr id="11" name="">
             <a:extLst xmlns:a="http://schemas.openxmlformats.org/drawingml/2006/main">
               <a:ext uri="{FF2B5EF4-FFF2-40B4-BE49-F238E27FC236}">
-                <a16:creationId xmlns:a16="http://schemas.microsoft.com/office/drawing/2014/main" id="{588475DA-D2E0-45D2-AA09-DC0D6F10FBA6}"/>
+                <a16:creationId xmlns:a16="http://schemas.microsoft.com/office/drawing/2014/main" id="{D6619575-A4D9-4F56-B468-DA56867C992C}"/>
               </a:ext>
             </a:extLst>
           </p:cNvPr>
@@ -9649,7 +9649,7 @@
           <p:cNvPr id="12" name="">
             <a:extLst xmlns:a="http://schemas.openxmlformats.org/drawingml/2006/main">
               <a:ext uri="{FF2B5EF4-FFF2-40B4-BE49-F238E27FC236}">
-                <a16:creationId xmlns:a16="http://schemas.microsoft.com/office/drawing/2014/main" id="{D50229C2-2202-40EC-9CE4-0CE6BF4C2925}"/>
+                <a16:creationId xmlns:a16="http://schemas.microsoft.com/office/drawing/2014/main" id="{2BA76AEA-5A2F-45D0-9451-785287062776}"/>
               </a:ext>
             </a:extLst>
           </p:cNvPr>
@@ -9704,7 +9704,7 @@
     </p:spTree>
     <p:extLst>
       <p:ext uri="{BB962C8B-B14F-4D97-AF65-F5344CB8AC3E}">
-        <p14:creationId xmlns:p14="http://schemas.microsoft.com/office/powerpoint/2010/main" val="1646636142"/>
+        <p14:creationId xmlns:p14="http://schemas.microsoft.com/office/powerpoint/2010/main" val="105425641"/>
       </p:ext>
     </p:extLst>
   </p:cSld>

</xml_diff>